<commit_message>
docs(presentacion): rebuild deck, guion and annexes with the published 10-chapter novel
runs.json final_novel: novela-ejemplo-a, published v1, 10 chapters, 10,645 words, 0 repair
rounds, 55 calls, $3.10, ~69 min; judge_novel 5/4/4/4 (0.88).

Co-Authored-By: Claude Opus 5.5 <noreply@anthropic.com>
Claude-Session: https://claude.ai/code/session_01SLwiWi2SmMJLEZNJMaEUwp
</commit_message>
<xml_diff>
--- a/presentacion/presentacion.pptx
+++ b/presentacion/presentacion.pptx
@@ -174,25 +174,28 @@
           </c:spPr>
           <c:cat>
             <c:strRef>
-              <c:f>Sheet1!$A$2:$A$7</c:f>
+              <c:f>Sheet1!$A$2:$A$8</c:f>
               <c:strCache>
-                <c:ptCount val="6"/>
+                <c:ptCount val="7"/>
                 <c:pt idx="0">
+                  <c:v>10 cap. final (publicada)</c:v>
+                </c:pt>
+                <c:pt idx="1">
                   <c:v>10 cap. intento 2 (bloq.)</c:v>
                 </c:pt>
-                <c:pt idx="1">
+                <c:pt idx="2">
                   <c:v>10 cap. intento 1 (bloq.)</c:v>
                 </c:pt>
-                <c:pt idx="2">
+                <c:pt idx="3">
                   <c:v>novela-infantil (3 cap.)</c:v>
                 </c:pt>
-                <c:pt idx="3">
+                <c:pt idx="4">
                   <c:v>b4-temporal (3 cap.)</c:v>
                 </c:pt>
-                <c:pt idx="4">
+                <c:pt idx="5">
                   <c:v>b3-injection (3 cap.)</c:v>
                 </c:pt>
-                <c:pt idx="5">
+                <c:pt idx="6">
                   <c:v>b2-infantil (3 cap.)</c:v>
                 </c:pt>
               </c:strCache>
@@ -200,26 +203,29 @@
           </c:cat>
           <c:val>
             <c:numRef>
-              <c:f>Sheet1!$B$2:$B$7</c:f>
+              <c:f>Sheet1!$B$2:$B$8</c:f>
               <c:numCache>
                 <c:formatCode>General</c:formatCode>
-                <c:ptCount val="6"/>
+                <c:ptCount val="7"/>
                 <c:pt idx="0">
+                  <c:v>3.1</c:v>
+                </c:pt>
+                <c:pt idx="1">
                   <c:v>4.61</c:v>
                 </c:pt>
-                <c:pt idx="1">
+                <c:pt idx="2">
                   <c:v>3.68</c:v>
                 </c:pt>
-                <c:pt idx="2">
+                <c:pt idx="3">
                   <c:v>0.85</c:v>
                 </c:pt>
-                <c:pt idx="3">
+                <c:pt idx="4">
                   <c:v>1.93</c:v>
                 </c:pt>
-                <c:pt idx="4">
+                <c:pt idx="5">
                   <c:v>1.02</c:v>
                 </c:pt>
-                <c:pt idx="5">
+                <c:pt idx="6">
                   <c:v>0.97</c:v>
                 </c:pt>
               </c:numCache>
@@ -1489,7 +1495,7 @@
           </a:p>
           <a:p>
             <a:r>
-              <a:t>- El intento final, con el tuning 2, se estaba generando al preparar esta presentación; si os preguntan, está en runs.json y en el log.</a:t>
+              <a:t>- El intento final, ya con el tuning 2, se publicó: 10 capítulos, 10.645 palabras, 0 rondas de reparación, 3,10 USD.</a:t>
             </a:r>
           </a:p>
           <a:p/>
@@ -1587,28 +1593,28 @@
           </a:p>
           <a:p>
             <a:r>
-              <a:t>- Esta es la novela que tenemos publicada de principio a fin con el pipeline real: 3 capítulos, 3.409 palabras, para una niña de siete años.</a:t>
-            </a:r>
-          </a:p>
-          <a:p>
-            <a:r>
-              <a:t>- Costó 0,85 USD y 21 min; necesitó 1 ronda de reparación y después pasó todo.</a:t>
-            </a:r>
-          </a:p>
-          <a:p>
-            <a:r>
-              <a:t>- Portada con dedicatoria, índice y fichas, exportada a PDF.</a:t>
-            </a:r>
-          </a:p>
-          <a:p>
-            <a:r>
-              <a:t>- La novela de 10 capítulos con el brief de ejemplo es la que se estaba generando con el tuning 2; si está, este hueco la muestra al reconstruir.</a:t>
+              <a:t>- Esta es la novela de ejemplo: 10 capítulos, 10.645 palabras, generada con el brief del README.</a:t>
+            </a:r>
+          </a:p>
+          <a:p>
+            <a:r>
+              <a:t>- Portada con dedicatoria, índice navegable y fichas, igual que en la web.</a:t>
+            </a:r>
+          </a:p>
+          <a:p>
+            <a:r>
+              <a:t>- Costó 3,10 USD y tardó 69 min, con 0 rondas de reparación.</a:t>
+            </a:r>
+          </a:p>
+          <a:p>
+            <a:r>
+              <a:t>- Pasó todos los validadores: nombres, cobertura, calendario, Lean y el juez de novela.</a:t>
             </a:r>
           </a:p>
           <a:p/>
           <a:p>
             <a:r>
-              <a:t>CIFRAS: 3 capítulos · 3.409 palabras · 0,85 USD · 21 min</a:t>
+              <a:t>CIFRAS: 10 capítulos · 10.645 palabras · 3,10 USD · 69 min</a:t>
             </a:r>
           </a:p>
           <a:p/>
@@ -1619,7 +1625,7 @@
           </a:p>
           <a:p>
             <a:r>
-              <a:t>(≈ 30 s)</a:t>
+              <a:t>(≈ 25 s)</a:t>
             </a:r>
           </a:p>
         </p:txBody>
@@ -1705,7 +1711,7 @@
           </a:p>
           <a:p>
             <a:r>
-              <a:t>- Las novelas de 10 capítulos completas costaron entre 3,68 USD y 4,61 USD, y eso incluye las rondas de reparación.</a:t>
+              <a:t>- La novela de 10 capítulos publicada costó 3,10 USD.</a:t>
             </a:r>
           </a:p>
           <a:p>
@@ -1721,7 +1727,7 @@
           <a:p/>
           <a:p>
             <a:r>
-              <a:t>CIFRAS: 0,35 USD/capítulo · 8 min/capítulo · 3,68 USD · 4,61 USD</a:t>
+              <a:t>CIFRAS: 0,35 USD/capítulo · 8 min/capítulo · 3,10 USD</a:t>
             </a:r>
           </a:p>
           <a:p/>
@@ -1732,7 +1738,7 @@
           </a:p>
           <a:p>
             <a:r>
-              <a:t>(≈ 40 s)</a:t>
+              <a:t>(≈ 35 s)</a:t>
             </a:r>
           </a:p>
         </p:txBody>
@@ -6506,7 +6512,7 @@
                 </a:solidFill>
                 <a:latin typeface="Calibri"/>
               </a:rPr>
-              <a:t>Repositorio storyMaker · commit 81e1518 · 2026</a:t>
+              <a:t>Repositorio storyMaker · commit c0a9e90 · 2026</a:t>
             </a:r>
           </a:p>
         </p:txBody>
@@ -11025,7 +11031,7 @@
                 </a:solidFill>
                 <a:latin typeface="Cambria"/>
               </a:rPr>
-              <a:t>Dos novelas bloqueadas: nada sin validar se publica</a:t>
+              <a:t>Dos bloqueadas, una publicada: nada sin validar sale</a:t>
             </a:r>
           </a:p>
         </p:txBody>
@@ -11619,7 +11625,7 @@
             </a:avLst>
           </a:prstGeom>
           <a:solidFill>
-            <a:srgbClr val="F3F5F7"/>
+            <a:srgbClr val="E3F4EA"/>
           </a:solidFill>
           <a:ln>
             <a:noFill/>
@@ -11709,11 +11715,11 @@
             <a:r>
               <a:rPr sz="2600" b="1" i="0">
                 <a:solidFill>
-                  <a:srgbClr val="7B8794"/>
+                  <a:srgbClr val="2F855A"/>
                 </a:solidFill>
                 <a:latin typeface="Cambria"/>
               </a:rPr>
-              <a:t>Pendiente</a:t>
+              <a:t>Publicada</a:t>
             </a:r>
           </a:p>
         </p:txBody>
@@ -11752,8 +11758,15 @@
                 </a:solidFill>
                 <a:latin typeface="Calibri"/>
               </a:rPr>
-              <a:t>Generándose con el tuning 2. </a:t>
-            </a:r>
+              <a:t>10 capítulos · 10.645 palabras</a:t>
+            </a:r>
+          </a:p>
+          <a:p>
+            <a:pPr algn="l">
+              <a:spcAft>
+                <a:spcPts val="400"/>
+              </a:spcAft>
+            </a:pPr>
             <a:r>
               <a:rPr sz="1200" b="0" i="0">
                 <a:solidFill>
@@ -11761,7 +11774,23 @@
                 </a:solidFill>
                 <a:latin typeface="Calibri"/>
               </a:rPr>
-              <a:t>Estado, coste, palabras y rondas se rellenan desde runs.json al reconstruir.</a:t>
+              <a:t>0 rondas de reparación · 69 min</a:t>
+            </a:r>
+          </a:p>
+          <a:p>
+            <a:pPr algn="l">
+              <a:spcAft>
+                <a:spcPts val="400"/>
+              </a:spcAft>
+            </a:pPr>
+            <a:r>
+              <a:rPr sz="1200" b="0" i="0">
+                <a:solidFill>
+                  <a:srgbClr val="1F2933"/>
+                </a:solidFill>
+                <a:latin typeface="Calibri"/>
+              </a:rPr>
+              <a:t>judge_novel: Aprobada: continuidad 5/5, tono 4/5, calidad narrativa 4/5, personalización natural 4/5 (0,88)</a:t>
             </a:r>
           </a:p>
         </p:txBody>
@@ -11796,7 +11825,7 @@
                 </a:solidFill>
                 <a:latin typeface="Cambria"/>
               </a:rPr>
-              <a:t>pendiente</a:t>
+              <a:t>3,10 USD</a:t>
             </a:r>
           </a:p>
         </p:txBody>
@@ -12052,14 +12081,14 @@
                 </a:solidFill>
                 <a:latin typeface="Cambria"/>
               </a:rPr>
-              <a:t>Una novela publicada de principio a fin, en PDF</a:t>
+              <a:t>Novela de 10 capítulos publicada y exportada a PDF</a:t>
             </a:r>
           </a:p>
         </p:txBody>
       </p:sp>
       <p:pic>
         <p:nvPicPr>
-          <p:cNvPr id="6" name="Picture 5" descr="novela-3-portada.png"/>
+          <p:cNvPr id="6" name="Picture 5" descr="novela-10-portada.png"/>
           <p:cNvPicPr>
             <a:picLocks noChangeAspect="1"/>
           </p:cNvPicPr>
@@ -12088,7 +12117,7 @@
       </p:pic>
       <p:pic>
         <p:nvPicPr>
-          <p:cNvPr id="7" name="Picture 6" descr="novela-3-indice.png"/>
+          <p:cNvPr id="7" name="Picture 6" descr="novela-10-indice.png"/>
           <p:cNvPicPr>
             <a:picLocks noChangeAspect="1"/>
           </p:cNvPicPr>
@@ -12117,7 +12146,7 @@
       </p:pic>
       <p:pic>
         <p:nvPicPr>
-          <p:cNvPr id="8" name="Picture 7" descr="novela-3-cap1.png"/>
+          <p:cNvPr id="8" name="Picture 7" descr="novela-10-cap1.png"/>
           <p:cNvPicPr>
             <a:picLocks noChangeAspect="1"/>
           </p:cNvPicPr>
@@ -12174,7 +12203,7 @@
                 </a:solidFill>
                 <a:latin typeface="Calibri"/>
               </a:rPr>
-              <a:t>ejemplos/novela-infantil-3-capitulos.pdf · portada, índice y capítulo 1</a:t>
+              <a:t>ejemplos/novela-ejemplo.pdf · portada, índice y capítulo 1</a:t>
             </a:r>
           </a:p>
         </p:txBody>
@@ -12209,7 +12238,7 @@
                 </a:solidFill>
                 <a:latin typeface="Cambria"/>
               </a:rPr>
-              <a:t>3</a:t>
+              <a:t>10</a:t>
             </a:r>
           </a:p>
         </p:txBody>
@@ -12279,7 +12308,7 @@
                 </a:solidFill>
                 <a:latin typeface="Cambria"/>
               </a:rPr>
-              <a:t>3.409</a:t>
+              <a:t>10.645</a:t>
             </a:r>
           </a:p>
         </p:txBody>
@@ -12349,7 +12378,7 @@
                 </a:solidFill>
                 <a:latin typeface="Cambria"/>
               </a:rPr>
-              <a:t>0,85 USD</a:t>
+              <a:t>3,10 USD</a:t>
             </a:r>
           </a:p>
         </p:txBody>
@@ -12419,7 +12448,7 @@
                 </a:solidFill>
                 <a:latin typeface="Cambria"/>
               </a:rPr>
-              <a:t>21 min</a:t>
+              <a:t>69 min</a:t>
             </a:r>
           </a:p>
         </p:txBody>
@@ -12489,7 +12518,7 @@
                 </a:solidFill>
                 <a:latin typeface="Cambria"/>
               </a:rPr>
-              <a:t>1</a:t>
+              <a:t>0</a:t>
             </a:r>
           </a:p>
         </p:txBody>
@@ -12546,7 +12575,7 @@
             </a:avLst>
           </a:prstGeom>
           <a:solidFill>
-            <a:srgbClr val="FDF3D8"/>
+            <a:srgbClr val="E3F4EA"/>
           </a:solidFill>
           <a:ln>
             <a:noFill/>
@@ -12605,7 +12634,7 @@
                 </a:solidFill>
                 <a:latin typeface="Calibri"/>
               </a:rPr>
-              <a:t>Brief b2-infantil, 3 capítulos. La novela de 10 capítulos (ejemplos/novela-ejemplo.pdf) está pendiente y sustituye a esta al reconstruir.</a:t>
+              <a:t>Brief de ejemplo del README (evals/briefs/ejemplo.json); todos los validadores en verde, incluido Lean y judge_novel.</a:t>
             </a:r>
           </a:p>
         </p:txBody>
@@ -12946,7 +12975,7 @@
                 </a:solidFill>
                 <a:latin typeface="Cambria"/>
               </a:rPr>
-              <a:t>3,68–4,61 USD</a:t>
+              <a:t>3,10 USD</a:t>
             </a:r>
           </a:p>
         </p:txBody>
@@ -12981,7 +13010,7 @@
                 </a:solidFill>
                 <a:latin typeface="Calibri"/>
               </a:rPr>
-              <a:t>novela de 10 capítulos (intentos completos)</a:t>
+              <a:t>novela de 10 capítulos</a:t>
             </a:r>
           </a:p>
         </p:txBody>
@@ -13016,7 +13045,7 @@
                 </a:solidFill>
                 <a:latin typeface="Cambria"/>
               </a:rPr>
-              <a:t>91–109 min</a:t>
+              <a:t>69 min</a:t>
             </a:r>
           </a:p>
         </p:txBody>
@@ -15781,40 +15810,6 @@
                 </a:solidFill>
                 <a:latin typeface="Calibri"/>
               </a:rPr>
-              <a:t>Novela de 10 capítulos: </a:t>
-            </a:r>
-            <a:r>
-              <a:rPr sz="1400" b="0" i="0">
-                <a:solidFill>
-                  <a:srgbClr val="1F2933"/>
-                </a:solidFill>
-                <a:latin typeface="Calibri"/>
-              </a:rPr>
-              <a:t>pendiente de publicar con el tuning 2.</a:t>
-            </a:r>
-          </a:p>
-          <a:p>
-            <a:pPr algn="l">
-              <a:spcAft>
-                <a:spcPts val="700"/>
-              </a:spcAft>
-            </a:pPr>
-            <a:r>
-              <a:rPr sz="900" b="0" i="0">
-                <a:solidFill>
-                  <a:srgbClr val="52606D"/>
-                </a:solidFill>
-                <a:latin typeface="Calibri"/>
-              </a:rPr>
-              <a:t>■  </a:t>
-            </a:r>
-            <a:r>
-              <a:rPr sz="1400" b="1" i="0">
-                <a:solidFill>
-                  <a:srgbClr val="1F2933"/>
-                </a:solidFill>
-                <a:latin typeface="Calibri"/>
-              </a:rPr>
               <a:t>Fichas de personajes sin versionar en la BD: </a:t>
             </a:r>
             <a:r>
@@ -17180,7 +17175,7 @@
                 </a:solidFill>
                 <a:latin typeface="Calibri"/>
               </a:rPr>
-              <a:t>Gracias · preguntas · presentacion/ · commit 81e1518</a:t>
+              <a:t>Gracias · preguntas · presentacion/ · commit c0a9e90</a:t>
             </a:r>
           </a:p>
         </p:txBody>

</xml_diff>

<commit_message>
docs(presentacion): add novela-ejemplo-b as the fourth 10-chapter attempt
runs.json ten_chapter_attempts gains novela-ejemplo-b (after tuning 2,
parallel): stopped_error (repair_limit) after 2 repair rounds, 91 calls,
6.05 USD, 148 min; judge_novel passed 0.88 but the Lean export failed on
an event without place, fixed by spec 007 AC 9.

The results slide lays out four columns (attempts that motivated a
tuning, the published one, then the parallel attempt) and the bottom
box mentions the fix; cost-chart labels follow the same numbering.
Deck, guion and annexes rebuilt.

Co-Authored-By: Claude Opus 5.5 <noreply@anthropic.com>
Claude-Session: https://claude.ai/code/session_01SLwiWi2SmMJLEZNJMaEUwp
</commit_message>
<xml_diff>
--- a/presentacion/presentacion.pptx
+++ b/presentacion/presentacion.pptx
@@ -174,28 +174,31 @@
           </c:spPr>
           <c:cat>
             <c:strRef>
-              <c:f>Sheet1!$A$2:$A$8</c:f>
+              <c:f>Sheet1!$A$2:$A$9</c:f>
               <c:strCache>
-                <c:ptCount val="7"/>
+                <c:ptCount val="8"/>
                 <c:pt idx="0">
                   <c:v>10 cap. final (publicada)</c:v>
                 </c:pt>
                 <c:pt idx="1">
+                  <c:v>10 cap. intento 4 (parada)</c:v>
+                </c:pt>
+                <c:pt idx="2">
                   <c:v>10 cap. intento 2 (bloq.)</c:v>
                 </c:pt>
-                <c:pt idx="2">
+                <c:pt idx="3">
                   <c:v>10 cap. intento 1 (bloq.)</c:v>
                 </c:pt>
-                <c:pt idx="3">
+                <c:pt idx="4">
                   <c:v>novela-infantil (3 cap.)</c:v>
                 </c:pt>
-                <c:pt idx="4">
+                <c:pt idx="5">
                   <c:v>b4-temporal (3 cap.)</c:v>
                 </c:pt>
-                <c:pt idx="5">
+                <c:pt idx="6">
                   <c:v>b3-injection (3 cap.)</c:v>
                 </c:pt>
-                <c:pt idx="6">
+                <c:pt idx="7">
                   <c:v>b2-infantil (3 cap.)</c:v>
                 </c:pt>
               </c:strCache>
@@ -203,29 +206,32 @@
           </c:cat>
           <c:val>
             <c:numRef>
-              <c:f>Sheet1!$B$2:$B$8</c:f>
+              <c:f>Sheet1!$B$2:$B$9</c:f>
               <c:numCache>
                 <c:formatCode>General</c:formatCode>
-                <c:ptCount val="7"/>
+                <c:ptCount val="8"/>
                 <c:pt idx="0">
                   <c:v>3.1</c:v>
                 </c:pt>
                 <c:pt idx="1">
+                  <c:v>6.05</c:v>
+                </c:pt>
+                <c:pt idx="2">
                   <c:v>4.61</c:v>
                 </c:pt>
-                <c:pt idx="2">
+                <c:pt idx="3">
                   <c:v>3.68</c:v>
                 </c:pt>
-                <c:pt idx="3">
+                <c:pt idx="4">
                   <c:v>0.85</c:v>
                 </c:pt>
-                <c:pt idx="4">
+                <c:pt idx="5">
                   <c:v>1.93</c:v>
                 </c:pt>
-                <c:pt idx="5">
+                <c:pt idx="6">
                   <c:v>1.02</c:v>
                 </c:pt>
-                <c:pt idx="6">
+                <c:pt idx="7">
                   <c:v>0.97</c:v>
                 </c:pt>
               </c:numCache>
@@ -1498,10 +1504,15 @@
               <a:t>- El intento final, ya con el tuning 2, se publicó: 10 capítulos, 10.645 palabras, 0 rondas de reparación, 3,10 USD.</a:t>
             </a:r>
           </a:p>
+          <a:p>
+            <a:r>
+              <a:t>- Y una ejecución paralela con el mismo código, novela-ejemplo-b, se paró: el juez de novela la aprobaba, pero un evento del plan no tenía lugar y la exportación a Lean falló; las 2 rondas reescribieron prosa que no podía arreglarlo. Coste 6,05 USD. Ahora el chequeo del plan rechaza ese evento y un error de exportación para la ejecución sin gastar rondas.</a:t>
+            </a:r>
+          </a:p>
           <a:p/>
           <a:p>
             <a:r>
-              <a:t>CIFRAS: intentos bloqueados: 3,68 USD y 4,61 USD · total gastado sin publicar: 8,29 USD</a:t>
+              <a:t>CIFRAS: intentos parados: 3,68 USD, 4,61 USD, 6,05 USD · total gastado sin publicar: 14,34 USD</a:t>
             </a:r>
           </a:p>
           <a:p/>
@@ -1512,7 +1523,7 @@
           </a:p>
           <a:p>
             <a:r>
-              <a:t>(≈ 70 s)</a:t>
+              <a:t>(≈ 95 s)</a:t>
             </a:r>
           </a:p>
         </p:txBody>
@@ -6512,7 +6523,7 @@
                 </a:solidFill>
                 <a:latin typeface="Calibri"/>
               </a:rPr>
-              <a:t>Repositorio storyMaker · commit c0a9e90 · 2026</a:t>
+              <a:t>Repositorio storyMaker · commit 096b00d · 2026</a:t>
             </a:r>
           </a:p>
         </p:txBody>
@@ -11031,7 +11042,7 @@
                 </a:solidFill>
                 <a:latin typeface="Cambria"/>
               </a:rPr>
-              <a:t>Dos bloqueadas, una publicada: nada sin validar sale</a:t>
+              <a:t>Tres paradas, una publicada: nada sin validar sale</a:t>
             </a:r>
           </a:p>
         </p:txBody>
@@ -11045,7 +11056,7 @@
         <p:spPr>
           <a:xfrm>
             <a:off x="548640" y="1600200"/>
-            <a:ext cx="3515258" cy="2971800"/>
+            <a:ext cx="2567863" cy="2971800"/>
           </a:xfrm>
           <a:prstGeom prst="roundRect">
             <a:avLst>
@@ -11090,8 +11101,8 @@
         </p:nvSpPr>
         <p:spPr>
           <a:xfrm>
-            <a:off x="777240" y="1737360"/>
-            <a:ext cx="3058058" cy="274320"/>
+            <a:off x="731520" y="1709928"/>
+            <a:ext cx="2202103" cy="365760"/>
           </a:xfrm>
           <a:prstGeom prst="rect">
             <a:avLst/>
@@ -11106,7 +11117,7 @@
           <a:p>
             <a:pPr algn="l"/>
             <a:r>
-              <a:rPr sz="1100" b="1" i="0">
+              <a:rPr sz="1000" b="1" i="0">
                 <a:solidFill>
                   <a:srgbClr val="C2551F"/>
                 </a:solidFill>
@@ -11125,8 +11136,8 @@
         </p:nvSpPr>
         <p:spPr>
           <a:xfrm>
-            <a:off x="777240" y="2011680"/>
-            <a:ext cx="3058058" cy="502920"/>
+            <a:off x="731520" y="2103120"/>
+            <a:ext cx="2202103" cy="457200"/>
           </a:xfrm>
           <a:prstGeom prst="rect">
             <a:avLst/>
@@ -11141,7 +11152,7 @@
           <a:p>
             <a:pPr algn="l"/>
             <a:r>
-              <a:rPr sz="2600" b="1" i="0">
+              <a:rPr sz="2400" b="1" i="0">
                 <a:solidFill>
                   <a:srgbClr val="C53030"/>
                 </a:solidFill>
@@ -11160,8 +11171,8 @@
         </p:nvSpPr>
         <p:spPr>
           <a:xfrm>
-            <a:off x="777240" y="2606040"/>
-            <a:ext cx="3058058" cy="1371600"/>
+            <a:off x="731520" y="2651760"/>
+            <a:ext cx="2202103" cy="1325880"/>
           </a:xfrm>
           <a:prstGeom prst="rect">
             <a:avLst/>
@@ -11176,11 +11187,11 @@
           <a:p>
             <a:pPr algn="l">
               <a:spcAft>
-                <a:spcPts val="400"/>
+                <a:spcPts val="300"/>
               </a:spcAft>
             </a:pPr>
             <a:r>
-              <a:rPr sz="1200" b="1" i="0">
+              <a:rPr sz="1100" b="1" i="0">
                 <a:solidFill>
                   <a:srgbClr val="1F2933"/>
                 </a:solidFill>
@@ -11189,7 +11200,7 @@
               <a:t>judge_novel: </a:t>
             </a:r>
             <a:r>
-              <a:rPr sz="1200" b="0" i="0">
+              <a:rPr sz="1100" b="0" i="0">
                 <a:solidFill>
                   <a:srgbClr val="1F2933"/>
                 </a:solidFill>
@@ -11201,17 +11212,17 @@
           <a:p>
             <a:pPr algn="l">
               <a:spcAft>
-                <a:spcPts val="400"/>
+                <a:spcPts val="300"/>
               </a:spcAft>
             </a:pPr>
             <a:r>
-              <a:rPr sz="1200" b="0" i="0">
+              <a:rPr sz="1100" b="0" i="0">
                 <a:solidFill>
                   <a:srgbClr val="52606D"/>
                 </a:solidFill>
                 <a:latin typeface="Calibri"/>
               </a:rPr>
-              <a:t>10 capítulos escritos · 1 ronda de reparación · 91 min</a:t>
+              <a:t>10 capítulos · 1 ronda de reparación · 91 min</a:t>
             </a:r>
           </a:p>
         </p:txBody>
@@ -11224,8 +11235,8 @@
         </p:nvSpPr>
         <p:spPr>
           <a:xfrm>
-            <a:off x="777240" y="3977639"/>
-            <a:ext cx="3058058" cy="457200"/>
+            <a:off x="731520" y="4023360"/>
+            <a:ext cx="2202103" cy="457200"/>
           </a:xfrm>
           <a:prstGeom prst="rect">
             <a:avLst/>
@@ -11259,7 +11270,7 @@
         </p:nvCxnSpPr>
         <p:spPr>
           <a:xfrm>
-            <a:off x="4082186" y="3063240"/>
+            <a:off x="3134791" y="3063240"/>
             <a:ext cx="237744" cy="0"/>
           </a:xfrm>
           <a:prstGeom prst="line">
@@ -11295,8 +11306,8 @@
         </p:nvSpPr>
         <p:spPr>
           <a:xfrm>
-            <a:off x="777240" y="4663440"/>
-            <a:ext cx="3058058" cy="320040"/>
+            <a:off x="731520" y="4663440"/>
+            <a:ext cx="2202103" cy="365760"/>
           </a:xfrm>
           <a:prstGeom prst="rect">
             <a:avLst/>
@@ -11311,7 +11322,7 @@
           <a:p>
             <a:pPr algn="l"/>
             <a:r>
-              <a:rPr sz="1200" b="1" i="0">
+              <a:rPr sz="1100" b="1" i="0">
                 <a:solidFill>
                   <a:srgbClr val="C2551F"/>
                 </a:solidFill>
@@ -11330,8 +11341,8 @@
         </p:nvSpPr>
         <p:spPr>
           <a:xfrm>
-            <a:off x="4338218" y="1600200"/>
-            <a:ext cx="3515258" cy="2971800"/>
+            <a:off x="3390823" y="1600200"/>
+            <a:ext cx="2567863" cy="2971800"/>
           </a:xfrm>
           <a:prstGeom prst="roundRect">
             <a:avLst>
@@ -11376,8 +11387,8 @@
         </p:nvSpPr>
         <p:spPr>
           <a:xfrm>
-            <a:off x="4566818" y="1737360"/>
-            <a:ext cx="3058058" cy="274320"/>
+            <a:off x="3573703" y="1709928"/>
+            <a:ext cx="2202103" cy="365760"/>
           </a:xfrm>
           <a:prstGeom prst="rect">
             <a:avLst/>
@@ -11392,7 +11403,7 @@
           <a:p>
             <a:pPr algn="l"/>
             <a:r>
-              <a:rPr sz="1100" b="1" i="0">
+              <a:rPr sz="1000" b="1" i="0">
                 <a:solidFill>
                   <a:srgbClr val="C2551F"/>
                 </a:solidFill>
@@ -11411,8 +11422,8 @@
         </p:nvSpPr>
         <p:spPr>
           <a:xfrm>
-            <a:off x="4566818" y="2011680"/>
-            <a:ext cx="3058058" cy="502920"/>
+            <a:off x="3573703" y="2103120"/>
+            <a:ext cx="2202103" cy="457200"/>
           </a:xfrm>
           <a:prstGeom prst="rect">
             <a:avLst/>
@@ -11427,7 +11438,7 @@
           <a:p>
             <a:pPr algn="l"/>
             <a:r>
-              <a:rPr sz="2600" b="1" i="0">
+              <a:rPr sz="2400" b="1" i="0">
                 <a:solidFill>
                   <a:srgbClr val="C53030"/>
                 </a:solidFill>
@@ -11446,8 +11457,8 @@
         </p:nvSpPr>
         <p:spPr>
           <a:xfrm>
-            <a:off x="4566818" y="2606040"/>
-            <a:ext cx="3058058" cy="1371600"/>
+            <a:off x="3573703" y="2651760"/>
+            <a:ext cx="2202103" cy="1325880"/>
           </a:xfrm>
           <a:prstGeom prst="rect">
             <a:avLst/>
@@ -11462,11 +11473,11 @@
           <a:p>
             <a:pPr algn="l">
               <a:spcAft>
-                <a:spcPts val="400"/>
+                <a:spcPts val="300"/>
               </a:spcAft>
             </a:pPr>
             <a:r>
-              <a:rPr sz="1200" b="1" i="0">
+              <a:rPr sz="1100" b="1" i="0">
                 <a:solidFill>
                   <a:srgbClr val="1F2933"/>
                 </a:solidFill>
@@ -11475,7 +11486,7 @@
               <a:t>judge_novel: </a:t>
             </a:r>
             <a:r>
-              <a:rPr sz="1200" b="0" i="0">
+              <a:rPr sz="1100" b="0" i="0">
                 <a:solidFill>
                   <a:srgbClr val="1F2933"/>
                 </a:solidFill>
@@ -11487,17 +11498,17 @@
           <a:p>
             <a:pPr algn="l">
               <a:spcAft>
-                <a:spcPts val="400"/>
+                <a:spcPts val="300"/>
               </a:spcAft>
             </a:pPr>
             <a:r>
-              <a:rPr sz="1200" b="0" i="0">
+              <a:rPr sz="1100" b="0" i="0">
                 <a:solidFill>
                   <a:srgbClr val="52606D"/>
                 </a:solidFill>
                 <a:latin typeface="Calibri"/>
               </a:rPr>
-              <a:t>10 capítulos escritos · 2 rondas de reparación · 109 min</a:t>
+              <a:t>10 capítulos · 2 rondas de reparación · 109 min</a:t>
             </a:r>
           </a:p>
         </p:txBody>
@@ -11510,8 +11521,8 @@
         </p:nvSpPr>
         <p:spPr>
           <a:xfrm>
-            <a:off x="4566818" y="3977639"/>
-            <a:ext cx="3058058" cy="457200"/>
+            <a:off x="3573703" y="4023360"/>
+            <a:ext cx="2202103" cy="457200"/>
           </a:xfrm>
           <a:prstGeom prst="rect">
             <a:avLst/>
@@ -11545,7 +11556,7 @@
         </p:nvCxnSpPr>
         <p:spPr>
           <a:xfrm>
-            <a:off x="7871764" y="3063240"/>
+            <a:off x="5976975" y="3063240"/>
             <a:ext cx="237744" cy="0"/>
           </a:xfrm>
           <a:prstGeom prst="line">
@@ -11581,8 +11592,8 @@
         </p:nvSpPr>
         <p:spPr>
           <a:xfrm>
-            <a:off x="4566818" y="4663440"/>
-            <a:ext cx="3058058" cy="320040"/>
+            <a:off x="3573703" y="4663440"/>
+            <a:ext cx="2202103" cy="365760"/>
           </a:xfrm>
           <a:prstGeom prst="rect">
             <a:avLst/>
@@ -11597,7 +11608,7 @@
           <a:p>
             <a:pPr algn="l"/>
             <a:r>
-              <a:rPr sz="1200" b="1" i="0">
+              <a:rPr sz="1100" b="1" i="0">
                 <a:solidFill>
                   <a:srgbClr val="C2551F"/>
                 </a:solidFill>
@@ -11616,8 +11627,8 @@
         </p:nvSpPr>
         <p:spPr>
           <a:xfrm>
-            <a:off x="8127796" y="1600200"/>
-            <a:ext cx="3515258" cy="2971800"/>
+            <a:off x="6233007" y="1600200"/>
+            <a:ext cx="2567863" cy="2971800"/>
           </a:xfrm>
           <a:prstGeom prst="roundRect">
             <a:avLst>
@@ -11662,8 +11673,8 @@
         </p:nvSpPr>
         <p:spPr>
           <a:xfrm>
-            <a:off x="8356396" y="1737360"/>
-            <a:ext cx="3058058" cy="274320"/>
+            <a:off x="6415887" y="1709928"/>
+            <a:ext cx="2202103" cy="365760"/>
           </a:xfrm>
           <a:prstGeom prst="rect">
             <a:avLst/>
@@ -11678,13 +11689,13 @@
           <a:p>
             <a:pPr algn="l"/>
             <a:r>
-              <a:rPr sz="1100" b="1" i="0">
+              <a:rPr sz="1000" b="1" i="0">
                 <a:solidFill>
                   <a:srgbClr val="C2551F"/>
                 </a:solidFill>
                 <a:latin typeface="Calibri"/>
               </a:rPr>
-              <a:t>INTENTO FINAL</a:t>
+              <a:t>INTENTO 3 · DESPUÉS DEL TUNING 2</a:t>
             </a:r>
           </a:p>
         </p:txBody>
@@ -11697,8 +11708,8 @@
         </p:nvSpPr>
         <p:spPr>
           <a:xfrm>
-            <a:off x="8356396" y="2011680"/>
-            <a:ext cx="3058058" cy="502920"/>
+            <a:off x="6415887" y="2103120"/>
+            <a:ext cx="2202103" cy="457200"/>
           </a:xfrm>
           <a:prstGeom prst="rect">
             <a:avLst/>
@@ -11713,7 +11724,7 @@
           <a:p>
             <a:pPr algn="l"/>
             <a:r>
-              <a:rPr sz="2600" b="1" i="0">
+              <a:rPr sz="2400" b="1" i="0">
                 <a:solidFill>
                   <a:srgbClr val="2F855A"/>
                 </a:solidFill>
@@ -11732,8 +11743,8 @@
         </p:nvSpPr>
         <p:spPr>
           <a:xfrm>
-            <a:off x="8356396" y="2606040"/>
-            <a:ext cx="3058058" cy="1371600"/>
+            <a:off x="6415887" y="2651760"/>
+            <a:ext cx="2202103" cy="1325880"/>
           </a:xfrm>
           <a:prstGeom prst="rect">
             <a:avLst/>
@@ -11748,11 +11759,11 @@
           <a:p>
             <a:pPr algn="l">
               <a:spcAft>
-                <a:spcPts val="400"/>
+                <a:spcPts val="300"/>
               </a:spcAft>
             </a:pPr>
             <a:r>
-              <a:rPr sz="1200" b="1" i="0">
+              <a:rPr sz="1100" b="1" i="0">
                 <a:solidFill>
                   <a:srgbClr val="1F2933"/>
                 </a:solidFill>
@@ -11764,11 +11775,11 @@
           <a:p>
             <a:pPr algn="l">
               <a:spcAft>
-                <a:spcPts val="400"/>
+                <a:spcPts val="300"/>
               </a:spcAft>
             </a:pPr>
             <a:r>
-              <a:rPr sz="1200" b="0" i="0">
+              <a:rPr sz="1100" b="0" i="0">
                 <a:solidFill>
                   <a:srgbClr val="1F2933"/>
                 </a:solidFill>
@@ -11780,11 +11791,11 @@
           <a:p>
             <a:pPr algn="l">
               <a:spcAft>
-                <a:spcPts val="400"/>
+                <a:spcPts val="300"/>
               </a:spcAft>
             </a:pPr>
             <a:r>
-              <a:rPr sz="1200" b="0" i="0">
+              <a:rPr sz="1100" b="0" i="0">
                 <a:solidFill>
                   <a:srgbClr val="1F2933"/>
                 </a:solidFill>
@@ -11803,8 +11814,8 @@
         </p:nvSpPr>
         <p:spPr>
           <a:xfrm>
-            <a:off x="8356396" y="3977639"/>
-            <a:ext cx="3058058" cy="457200"/>
+            <a:off x="6415887" y="4023360"/>
+            <a:ext cx="2202103" cy="457200"/>
           </a:xfrm>
           <a:prstGeom prst="rect">
             <a:avLst/>
@@ -11833,6 +11844,256 @@
       <p:sp>
         <p:nvSpPr>
           <p:cNvPr id="25" name="Rounded Rectangle 24"/>
+          <p:cNvSpPr/>
+          <p:nvPr/>
+        </p:nvSpPr>
+        <p:spPr>
+          <a:xfrm>
+            <a:off x="9075191" y="1600200"/>
+            <a:ext cx="2567863" cy="2971800"/>
+          </a:xfrm>
+          <a:prstGeom prst="roundRect">
+            <a:avLst>
+              <a:gd name="adj" fmla="val 8000"/>
+            </a:avLst>
+          </a:prstGeom>
+          <a:solidFill>
+            <a:srgbClr val="FBE4E4"/>
+          </a:solidFill>
+          <a:ln>
+            <a:noFill/>
+          </a:ln>
+          <a:effectLst/>
+        </p:spPr>
+        <p:style>
+          <a:lnRef idx="1">
+            <a:schemeClr val="accent1"/>
+          </a:lnRef>
+          <a:fillRef idx="3">
+            <a:schemeClr val="accent1"/>
+          </a:fillRef>
+          <a:effectRef idx="2">
+            <a:schemeClr val="accent1"/>
+          </a:effectRef>
+          <a:fontRef idx="minor">
+            <a:schemeClr val="lt1"/>
+          </a:fontRef>
+        </p:style>
+        <p:txBody>
+          <a:bodyPr rtlCol="0" anchor="ctr"/>
+          <a:lstStyle/>
+          <a:p>
+            <a:pPr algn="ctr"/>
+          </a:p>
+        </p:txBody>
+      </p:sp>
+      <p:sp>
+        <p:nvSpPr>
+          <p:cNvPr id="26" name="TextBox 25"/>
+          <p:cNvSpPr txBox="1"/>
+          <p:nvPr/>
+        </p:nvSpPr>
+        <p:spPr>
+          <a:xfrm>
+            <a:off x="9258071" y="1709928"/>
+            <a:ext cx="2202103" cy="365760"/>
+          </a:xfrm>
+          <a:prstGeom prst="rect">
+            <a:avLst/>
+          </a:prstGeom>
+          <a:noFill/>
+        </p:spPr>
+        <p:txBody>
+          <a:bodyPr wrap="square" lIns="0" rIns="0" tIns="0" bIns="0" anchor="t">
+            <a:spAutoFit/>
+          </a:bodyPr>
+          <a:lstStyle/>
+          <a:p>
+            <a:pPr algn="l"/>
+            <a:r>
+              <a:rPr sz="1000" b="1" i="0">
+                <a:solidFill>
+                  <a:srgbClr val="C2551F"/>
+                </a:solidFill>
+                <a:latin typeface="Calibri"/>
+              </a:rPr>
+              <a:t>INTENTO 4 · DESPUÉS DEL TUNING 2 (PARALELA)</a:t>
+            </a:r>
+          </a:p>
+        </p:txBody>
+      </p:sp>
+      <p:sp>
+        <p:nvSpPr>
+          <p:cNvPr id="27" name="TextBox 26"/>
+          <p:cNvSpPr txBox="1"/>
+          <p:nvPr/>
+        </p:nvSpPr>
+        <p:spPr>
+          <a:xfrm>
+            <a:off x="9258071" y="2103120"/>
+            <a:ext cx="2202103" cy="457200"/>
+          </a:xfrm>
+          <a:prstGeom prst="rect">
+            <a:avLst/>
+          </a:prstGeom>
+          <a:noFill/>
+        </p:spPr>
+        <p:txBody>
+          <a:bodyPr wrap="square" lIns="0" rIns="0" tIns="0" bIns="0" anchor="t">
+            <a:spAutoFit/>
+          </a:bodyPr>
+          <a:lstStyle/>
+          <a:p>
+            <a:pPr algn="l"/>
+            <a:r>
+              <a:rPr sz="2400" b="1" i="0">
+                <a:solidFill>
+                  <a:srgbClr val="C53030"/>
+                </a:solidFill>
+                <a:latin typeface="Cambria"/>
+              </a:rPr>
+              <a:t>Parada</a:t>
+            </a:r>
+          </a:p>
+        </p:txBody>
+      </p:sp>
+      <p:sp>
+        <p:nvSpPr>
+          <p:cNvPr id="28" name="TextBox 27"/>
+          <p:cNvSpPr txBox="1"/>
+          <p:nvPr/>
+        </p:nvSpPr>
+        <p:spPr>
+          <a:xfrm>
+            <a:off x="9258071" y="2651760"/>
+            <a:ext cx="2202103" cy="1325880"/>
+          </a:xfrm>
+          <a:prstGeom prst="rect">
+            <a:avLst/>
+          </a:prstGeom>
+          <a:noFill/>
+        </p:spPr>
+        <p:txBody>
+          <a:bodyPr wrap="square" lIns="0" rIns="0" tIns="0" bIns="0" anchor="t">
+            <a:spAutoFit/>
+          </a:bodyPr>
+          <a:lstStyle/>
+          <a:p>
+            <a:pPr algn="l">
+              <a:spcAft>
+                <a:spcPts val="300"/>
+              </a:spcAft>
+            </a:pPr>
+            <a:r>
+              <a:rPr sz="1100" b="1" i="0">
+                <a:solidFill>
+                  <a:srgbClr val="1F2933"/>
+                </a:solidFill>
+                <a:latin typeface="Calibri"/>
+              </a:rPr>
+              <a:t>lean_chronology: </a:t>
+            </a:r>
+            <a:r>
+              <a:rPr sz="1100" b="0" i="0">
+                <a:solidFill>
+                  <a:srgbClr val="1F2933"/>
+                </a:solidFill>
+                <a:latin typeface="Calibri"/>
+              </a:rPr>
+              <a:t>error de exportación: un evento del plan sin lugar (events[21].place_id nulo); judge_novel aprobado (0,88)</a:t>
+            </a:r>
+          </a:p>
+          <a:p>
+            <a:pPr algn="l">
+              <a:spcAft>
+                <a:spcPts val="300"/>
+              </a:spcAft>
+            </a:pPr>
+            <a:r>
+              <a:rPr sz="1100" b="0" i="0">
+                <a:solidFill>
+                  <a:srgbClr val="52606D"/>
+                </a:solidFill>
+                <a:latin typeface="Calibri"/>
+              </a:rPr>
+              <a:t>10 capítulos · 2 rondas de reparación · 148 min</a:t>
+            </a:r>
+          </a:p>
+        </p:txBody>
+      </p:sp>
+      <p:sp>
+        <p:nvSpPr>
+          <p:cNvPr id="29" name="TextBox 28"/>
+          <p:cNvSpPr txBox="1"/>
+          <p:nvPr/>
+        </p:nvSpPr>
+        <p:spPr>
+          <a:xfrm>
+            <a:off x="9258071" y="4023360"/>
+            <a:ext cx="2202103" cy="457200"/>
+          </a:xfrm>
+          <a:prstGeom prst="rect">
+            <a:avLst/>
+          </a:prstGeom>
+          <a:noFill/>
+        </p:spPr>
+        <p:txBody>
+          <a:bodyPr wrap="square" lIns="0" rIns="0" tIns="0" bIns="0" anchor="t">
+            <a:spAutoFit/>
+          </a:bodyPr>
+          <a:lstStyle/>
+          <a:p>
+            <a:pPr algn="l"/>
+            <a:r>
+              <a:rPr sz="2200" b="1" i="0">
+                <a:solidFill>
+                  <a:srgbClr val="1F2933"/>
+                </a:solidFill>
+                <a:latin typeface="Cambria"/>
+              </a:rPr>
+              <a:t>6,05 USD</a:t>
+            </a:r>
+          </a:p>
+        </p:txBody>
+      </p:sp>
+      <p:sp>
+        <p:nvSpPr>
+          <p:cNvPr id="30" name="TextBox 29"/>
+          <p:cNvSpPr txBox="1"/>
+          <p:nvPr/>
+        </p:nvSpPr>
+        <p:spPr>
+          <a:xfrm>
+            <a:off x="9258071" y="4663440"/>
+            <a:ext cx="2202103" cy="365760"/>
+          </a:xfrm>
+          <a:prstGeom prst="rect">
+            <a:avLst/>
+          </a:prstGeom>
+          <a:noFill/>
+        </p:spPr>
+        <p:txBody>
+          <a:bodyPr wrap="square" lIns="0" rIns="0" tIns="0" bIns="0" anchor="t">
+            <a:spAutoFit/>
+          </a:bodyPr>
+          <a:lstStyle/>
+          <a:p>
+            <a:pPr algn="l"/>
+            <a:r>
+              <a:rPr sz="1100" b="1" i="0">
+                <a:solidFill>
+                  <a:srgbClr val="C2551F"/>
+                </a:solidFill>
+                <a:latin typeface="Calibri"/>
+              </a:rPr>
+              <a:t>→ motivó el arreglo del plan</a:t>
+            </a:r>
+          </a:p>
+        </p:txBody>
+      </p:sp>
+      <p:sp>
+        <p:nvSpPr>
+          <p:cNvPr id="31" name="Rounded Rectangle 30"/>
           <p:cNvSpPr/>
           <p:nvPr/>
         </p:nvSpPr>
@@ -11878,7 +12139,7 @@
       </p:sp>
       <p:sp>
         <p:nvSpPr>
-          <p:cNvPr id="26" name="TextBox 25"/>
+          <p:cNvPr id="32" name="TextBox 31"/>
           <p:cNvSpPr txBox="1"/>
           <p:nvPr/>
         </p:nvSpPr>
@@ -11898,9 +12159,13 @@
           </a:bodyPr>
           <a:lstStyle/>
           <a:p>
-            <a:pPr algn="l"/>
-            <a:r>
-              <a:rPr sz="1200" b="1" i="0">
+            <a:pPr algn="l">
+              <a:spcAft>
+                <a:spcPts val="300"/>
+              </a:spcAft>
+            </a:pPr>
+            <a:r>
+              <a:rPr sz="1100" b="1" i="0">
                 <a:solidFill>
                   <a:srgbClr val="C2551F"/>
                 </a:solidFill>
@@ -11909,13 +12174,38 @@
               <a:t>Tuning 2 · calendario determinista. </a:t>
             </a:r>
             <a:r>
-              <a:rPr sz="1200" b="0" i="0">
+              <a:rPr sz="1100" b="0" i="0">
                 <a:solidFill>
                   <a:srgbClr val="FFFFFF"/>
                 </a:solidFill>
                 <a:latin typeface="Calibri"/>
               </a:rPr>
               <a:t>El writer inventaba el día de la semana y cada reparación inventaba otro. Ahora el plan corrige los días en Python (calendar_facts.py), writer y editor reciben plan/calendar.txt con fechas y cifras canónicas, y calendar_consistency para en chapter_close «…pero el 23 de junio de 2026 es martes».</a:t>
+            </a:r>
+          </a:p>
+          <a:p>
+            <a:pPr algn="l">
+              <a:spcAft>
+                <a:spcPts val="300"/>
+              </a:spcAft>
+            </a:pPr>
+            <a:r>
+              <a:rPr sz="1100" b="1" i="0">
+                <a:solidFill>
+                  <a:srgbClr val="C2551F"/>
+                </a:solidFill>
+                <a:latin typeface="Calibri"/>
+              </a:rPr>
+              <a:t>Después · eventos con lugar. </a:t>
+            </a:r>
+            <a:r>
+              <a:rPr sz="1100" b="0" i="0">
+                <a:solidFill>
+                  <a:srgbClr val="FFFFFF"/>
+                </a:solidFill>
+                <a:latin typeface="Calibri"/>
+              </a:rPr>
+              <a:t>La paralela se paró por un evento del plan sin lugar que Lean no podía exportar: ahora el chequeo del plan lo rechaza y un error de exportación no gasta rondas.</a:t>
             </a:r>
           </a:p>
         </p:txBody>
@@ -17175,7 +17465,7 @@
                 </a:solidFill>
                 <a:latin typeface="Calibri"/>
               </a:rPr>
-              <a:t>Gracias · preguntas · presentacion/ · commit c0a9e90</a:t>
+              <a:t>Gracias · preguntas · presentacion/ · commit 096b00d</a:t>
             </a:r>
           </a:p>
         </p:txBody>

</xml_diff>